<commit_message>
PowerPoint template on the media and tools pages; decks regenerated with a clean stamp
Co-Authored-By: Claude Opus 5.5 <noreply@anthropic.com>
</commit_message>
<xml_diff>
--- a/docs/downloads/vellum-slides-dark.pptx
+++ b/docs/downloads/vellum-slides-dark.pptx
@@ -5840,7 +5840,7 @@
           <a:bodyPr/>
           <a:p>
             <a:r>
-              <a:t>Vellum slides, dark · make_pptx.py · git 4c16514-dirty</a:t>
+              <a:t>Vellum slides, dark · make_pptx.py · git cdde20e</a:t>
             </a:r>
           </a:p>
         </p:txBody>
@@ -6224,7 +6224,7 @@
           <a:bodyPr/>
           <a:p>
             <a:r>
-              <a:t>Data: UN World Population Prospects (2024), processed by Our World in Data, CC BY 4.0 · make_pptx.py · git 4c16514-dirty</a:t>
+              <a:t>Data: UN World Population Prospects (2024), processed by Our World in Data, CC BY 4.0 · make_pptx.py · git cdde20e</a:t>
             </a:r>
           </a:p>
         </p:txBody>
@@ -7615,7 +7615,7 @@
           <a:bodyPr/>
           <a:p>
             <a:r>
-              <a:t>Data: UN World Population Prospects (2024), processed by Our World in Data, CC BY 4.0 · make_pptx.py · git 4c16514-dirty</a:t>
+              <a:t>Data: UN World Population Prospects (2024), processed by Our World in Data, CC BY 4.0 · make_pptx.py · git cdde20e</a:t>
             </a:r>
           </a:p>
         </p:txBody>
@@ -7722,7 +7722,7 @@
           </a:p>
           <a:p>
             <a:r>
-              <a:t>Downloads: vellum-slides-light.pptx, vellum-slides-dark.pptx, vellum-office.tsv · git 4c16514-dirty</a:t>
+              <a:t>Downloads: vellum-slides-light.pptx, vellum-slides-dark.pptx, vellum-office.tsv · git cdde20e</a:t>
             </a:r>
           </a:p>
         </p:txBody>
@@ -7742,7 +7742,7 @@
           <a:bodyPr/>
           <a:p>
             <a:r>
-              <a:t>Vellum slides, dark · make_pptx.py · git 4c16514-dirty</a:t>
+              <a:t>Vellum slides, dark · make_pptx.py · git cdde20e</a:t>
             </a:r>
           </a:p>
         </p:txBody>
@@ -7878,7 +7878,7 @@
           <a:bodyPr/>
           <a:p>
             <a:r>
-              <a:t>Colours: vellum-office.tsv · fonts: vellum.json · make_pptx.py · git 4c16514-dirty</a:t>
+              <a:t>Colours: vellum-office.tsv · fonts: vellum.json · make_pptx.py · git cdde20e</a:t>
             </a:r>
           </a:p>
         </p:txBody>
@@ -8000,7 +8000,7 @@
           <a:bodyPr/>
           <a:p>
             <a:r>
-              <a:t>Vellum slides, dark · make_pptx.py · git 4c16514-dirty</a:t>
+              <a:t>Vellum slides, dark · make_pptx.py · git cdde20e</a:t>
             </a:r>
           </a:p>
         </p:txBody>
@@ -8135,7 +8135,7 @@
           <a:bodyPr/>
           <a:p>
             <a:r>
-              <a:t>Data: NOAA GML and Scripps, via vega-datasets 2.8.0 · co2_keeling.py · git 4c16514-dirty</a:t>
+              <a:t>Data: NOAA GML and Scripps, via vega-datasets 2.8.0 · co2_keeling.py · git cdde20e</a:t>
             </a:r>
           </a:p>
         </p:txBody>
@@ -8270,7 +8270,7 @@
           <a:bodyPr/>
           <a:p>
             <a:r>
-              <a:t>Data: UN WPP (2024), HMD (2024) and others, processed by Our World in Data · life_small_multiples.py · git 4c16514-dirty</a:t>
+              <a:t>Data: UN WPP (2024), HMD (2024) and others, processed by Our World in Data · life_small_multiples.py · git cdde20e</a:t>
             </a:r>
           </a:p>
         </p:txBody>
@@ -8481,7 +8481,7 @@
           <a:bodyPr/>
           <a:p>
             <a:r>
-              <a:t>Analytic function landscape(z1, z2) in _common.py, illustrative · landscape_3d.py · git 4c16514-dirty</a:t>
+              <a:t>Analytic function landscape(z1, z2) in _common.py, illustrative · landscape_3d.py · git cdde20e</a:t>
             </a:r>
           </a:p>
         </p:txBody>
@@ -8603,7 +8603,7 @@
           <a:bodyPr/>
           <a:p>
             <a:r>
-              <a:t>Vellum slides, dark · make_pptx.py · git 4c16514-dirty</a:t>
+              <a:t>Vellum slides, dark · make_pptx.py · git cdde20e</a:t>
             </a:r>
           </a:p>
         </p:txBody>
@@ -8734,7 +8734,7 @@
           <a:bodyPr/>
           <a:p>
             <a:r>
-              <a:t>Data: UN World Population Prospects (2024), processed by Our World in Data, CC BY 4.0 · make_pptx.py · git 4c16514-dirty</a:t>
+              <a:t>Data: UN World Population Prospects (2024), processed by Our World in Data, CC BY 4.0 · make_pptx.py · git cdde20e</a:t>
             </a:r>
           </a:p>
         </p:txBody>
@@ -8865,7 +8865,7 @@
           <a:bodyPr/>
           <a:p>
             <a:r>
-              <a:t>Data: Ember (2026) and Energy Institute (2025), via Our World in Data, CC BY 4.0 · make_pptx.py · git 4c16514-dirty</a:t>
+              <a:t>Data: Ember (2026) and Energy Institute (2025), via Our World in Data, CC BY 4.0 · make_pptx.py · git cdde20e</a:t>
             </a:r>
           </a:p>
         </p:txBody>
@@ -9039,7 +9039,7 @@
           <a:bodyPr/>
           <a:p>
             <a:r>
-              <a:t>Data: Ember (2026) and Energy Institute (2025), via Our World in Data, CC BY 4.0 · make_pptx.py · git 4c16514-dirty</a:t>
+              <a:t>Data: Ember (2026) and Energy Institute (2025), via Our World in Data, CC BY 4.0 · make_pptx.py · git cdde20e</a:t>
             </a:r>
           </a:p>
         </p:txBody>

</xml_diff>